<commit_message>
docs: kwartaal-roadmap slide (Q0-Q4) + horizon-economie + 'verkoop een jaar met uitstapmoment' in deck en prijs-en-verhaal
</commit_message>
<xml_diff>
--- a/docs/mister-chameleon-demo.pptx
+++ b/docs/mister-chameleon-demo.pptx
@@ -22,9 +22,10 @@
     <p:sldId id="270" r:id="rId16"/>
     <p:sldId id="271" r:id="rId17"/>
     <p:sldId id="272" r:id="rId18"/>
+    <p:sldId id="273" r:id="rId19"/>
   </p:sldIdLst>
   <p:notesMasterIdLst>
-    <p:notesMasterId r:id="rId19"/>
+    <p:notesMasterId r:id="rId20"/>
   </p:notesMasterIdLst>
   <p:sldSz cx="12192000" cy="6858000"/>
   <p:notesSz cx="6858000" cy="12192000"/>
@@ -1134,7 +1135,7 @@
           <a:p>
             <a:r>
               <a:rPr lang="en-US" dirty="0"/>
-              <a:t>Toon eerst de baseline (default), dan per persona verversen. Sluit af met de holdout: het meetbaarheids-argument.</a:t>
+              <a:t/>
             </a:r>
             <a:endParaRPr lang="en-US" dirty="0"/>
           </a:p>
@@ -1222,7 +1223,7 @@
           <a:p>
             <a:r>
               <a:rPr lang="en-US" dirty="0"/>
-              <a:t/>
+              <a:t>Toon eerst de baseline (default), dan per persona verversen. Sluit af met de holdout: het meetbaarheids-argument.</a:t>
             </a:r>
             <a:endParaRPr lang="en-US" dirty="0"/>
           </a:p>
@@ -1246,6 +1247,94 @@
             <a:fld id="{F7021451-1387-4CA6-816F-3879F97B5CBC}" type="slidenum">
               <a:rPr lang="en-US"/>
               <a:t>17</a:t>
+            </a:fld>
+            <a:endParaRPr lang="en-US"/>
+          </a:p>
+        </p:txBody>
+      </p:sp>
+    </p:spTree>
+    <p:extLst>
+      <p:ext uri="{BB962C8B-B14F-4D97-AF65-F5344CB8AC3E}">
+        <p14:creationId xmlns:p14="http://schemas.microsoft.com/office/powerpoint/2010/main" val="1024086991"/>
+      </p:ext>
+    </p:extLst>
+  </p:cSld>
+  <p:clrMapOvr>
+    <a:masterClrMapping/>
+  </p:clrMapOvr>
+</p:notes>
+</file>
+
+<file path=ppt/notesSlides/notesSlide18.xml><?xml version="1.0" encoding="utf-8"?>
+<p:notes xmlns:a="http://schemas.openxmlformats.org/drawingml/2006/main" xmlns:r="http://schemas.openxmlformats.org/officeDocument/2006/relationships" xmlns:p="http://schemas.openxmlformats.org/presentationml/2006/main">
+  <p:cSld>
+    <p:spTree>
+      <p:nvGrpSpPr>
+        <p:cNvPr id="1" name=""/>
+        <p:cNvGrpSpPr/>
+        <p:nvPr/>
+      </p:nvGrpSpPr>
+      <p:grpSpPr>
+        <a:xfrm>
+          <a:off x="0" y="0"/>
+          <a:ext cx="0" cy="0"/>
+          <a:chOff x="0" y="0"/>
+          <a:chExt cx="0" cy="0"/>
+        </a:xfrm>
+      </p:grpSpPr>
+      <p:sp>
+        <p:nvSpPr>
+          <p:cNvPr id="2" name="Slide Image Placeholder 1"/>
+          <p:cNvSpPr>
+            <a:spLocks noGrp="1" noRot="1" noChangeAspect="1"/>
+          </p:cNvSpPr>
+          <p:nvPr>
+            <p:ph type="sldImg"/>
+          </p:nvPr>
+        </p:nvSpPr>
+        <p:spPr/>
+      </p:sp>
+      <p:sp>
+        <p:nvSpPr>
+          <p:cNvPr id="3" name="Notes Placeholder 2"/>
+          <p:cNvSpPr>
+            <a:spLocks noGrp="1"/>
+          </p:cNvSpPr>
+          <p:nvPr>
+            <p:ph type="body" idx="1"/>
+          </p:nvPr>
+        </p:nvSpPr>
+        <p:spPr/>
+        <p:txBody>
+          <a:bodyPr/>
+          <a:lstStyle/>
+          <a:p>
+            <a:r>
+              <a:rPr lang="en-US" dirty="0"/>
+              <a:t/>
+            </a:r>
+            <a:endParaRPr lang="en-US" dirty="0"/>
+          </a:p>
+        </p:txBody>
+      </p:sp>
+      <p:sp>
+        <p:nvSpPr>
+          <p:cNvPr id="4" name="Slide Number Placeholder 3"/>
+          <p:cNvSpPr>
+            <a:spLocks noGrp="1"/>
+          </p:cNvSpPr>
+          <p:nvPr>
+            <p:ph type="sldNum" sz="quarter" idx="10"/>
+          </p:nvPr>
+        </p:nvSpPr>
+        <p:spPr/>
+        <p:txBody>
+          <a:bodyPr/>
+          <a:lstStyle/>
+          <a:p>
+            <a:fld id="{F7021451-1387-4CA6-816F-3879F97B5CBC}" type="slidenum">
+              <a:rPr lang="en-US"/>
+              <a:t>18</a:t>
             </a:fld>
             <a:endParaRPr lang="en-US"/>
           </a:p>
@@ -7416,6 +7505,932 @@
     <p:bg>
       <p:bgPr>
         <a:solidFill>
+          <a:srgbClr val="FFFFFF"/>
+        </a:solidFill>
+      </p:bgPr>
+    </p:bg>
+    <p:spTree>
+      <p:nvGrpSpPr>
+        <p:cNvPr id="1" name=""/>
+        <p:cNvGrpSpPr/>
+        <p:nvPr/>
+      </p:nvGrpSpPr>
+      <p:grpSpPr>
+        <a:xfrm>
+          <a:off x="0" y="0"/>
+          <a:ext cx="0" cy="0"/>
+          <a:chOff x="0" y="0"/>
+          <a:chExt cx="0" cy="0"/>
+        </a:xfrm>
+      </p:grpSpPr>
+      <p:sp>
+        <p:nvSpPr>
+          <p:cNvPr id="2" name="Text 0"/>
+          <p:cNvSpPr/>
+          <p:nvPr/>
+        </p:nvSpPr>
+        <p:spPr>
+          <a:xfrm>
+            <a:off x="640080" y="457200"/>
+            <a:ext cx="10972800" cy="731520"/>
+          </a:xfrm>
+          <a:prstGeom prst="rect">
+            <a:avLst/>
+          </a:prstGeom>
+          <a:noFill/>
+          <a:ln/>
+        </p:spPr>
+        <p:txBody>
+          <a:bodyPr wrap="square" lIns="0" tIns="0" rIns="0" bIns="0" rtlCol="0" anchor="ctr"/>
+          <a:lstStyle/>
+          <a:p>
+            <a:pPr indent="0" marL="0">
+              <a:buNone/>
+            </a:pPr>
+            <a:r>
+              <a:rPr lang="en-US" sz="3000" b="1" dirty="0">
+                <a:solidFill>
+                  <a:srgbClr val="17303A"/>
+                </a:solidFill>
+                <a:latin typeface="Cambria" pitchFamily="34" charset="0"/>
+                <a:ea typeface="Cambria" pitchFamily="34" charset="-122"/>
+                <a:cs typeface="Cambria" pitchFamily="34" charset="-120"/>
+              </a:rPr>
+              <a:t>Denk in kwartalen</a:t>
+            </a:r>
+            <a:endParaRPr lang="en-US" sz="3000" dirty="0"/>
+          </a:p>
+        </p:txBody>
+      </p:sp>
+      <p:sp>
+        <p:nvSpPr>
+          <p:cNvPr id="3" name="Text 1"/>
+          <p:cNvSpPr/>
+          <p:nvPr/>
+        </p:nvSpPr>
+        <p:spPr>
+          <a:xfrm>
+            <a:off x="658368" y="1115568"/>
+            <a:ext cx="10972800" cy="457200"/>
+          </a:xfrm>
+          <a:prstGeom prst="rect">
+            <a:avLst/>
+          </a:prstGeom>
+          <a:noFill/>
+          <a:ln/>
+        </p:spPr>
+        <p:txBody>
+          <a:bodyPr wrap="square" lIns="0" tIns="0" rIns="0" bIns="0" rtlCol="0" anchor="ctr"/>
+          <a:lstStyle/>
+          <a:p>
+            <a:pPr indent="0" marL="0">
+              <a:buNone/>
+            </a:pPr>
+            <a:r>
+              <a:rPr lang="en-US" sz="1500" dirty="0">
+                <a:solidFill>
+                  <a:srgbClr val="5F7B88"/>
+                </a:solidFill>
+                <a:latin typeface="Calibri" pitchFamily="34" charset="0"/>
+                <a:ea typeface="Calibri" pitchFamily="34" charset="-122"/>
+                <a:cs typeface="Calibri" pitchFamily="34" charset="-120"/>
+              </a:rPr>
+              <a:t>Het instrument heeft tijd nodig. Zet de verwachting vooraf: Q1 is inrichten en leren, niet oogsten.</a:t>
+            </a:r>
+            <a:endParaRPr lang="en-US" sz="1500" dirty="0"/>
+          </a:p>
+        </p:txBody>
+      </p:sp>
+      <p:sp>
+        <p:nvSpPr>
+          <p:cNvPr id="4" name="Shape 2"/>
+          <p:cNvSpPr/>
+          <p:nvPr/>
+        </p:nvSpPr>
+        <p:spPr>
+          <a:xfrm>
+            <a:off x="640080" y="1783080"/>
+            <a:ext cx="2624328" cy="2377440"/>
+          </a:xfrm>
+          <a:prstGeom prst="roundRect">
+            <a:avLst>
+              <a:gd name="adj" fmla="val 3462"/>
+            </a:avLst>
+          </a:prstGeom>
+          <a:solidFill>
+            <a:srgbClr val="EDF5F5"/>
+          </a:solidFill>
+          <a:ln/>
+          <a:effectLst>
+            <a:outerShdw sx="100000" sy="100000" kx="0" ky="0" algn="bl" rotWithShape="0" blurRad="76200" dist="25400" dir="5400000">
+              <a:srgbClr val="9FB6B6">
+                <a:alpha val="28000"/>
+              </a:srgbClr>
+            </a:outerShdw>
+          </a:effectLst>
+        </p:spPr>
+      </p:sp>
+      <p:sp>
+        <p:nvSpPr>
+          <p:cNvPr id="5" name="Shape 3"/>
+          <p:cNvSpPr/>
+          <p:nvPr/>
+        </p:nvSpPr>
+        <p:spPr>
+          <a:xfrm>
+            <a:off x="896112" y="2020824"/>
+            <a:ext cx="914400" cy="457200"/>
+          </a:xfrm>
+          <a:prstGeom prst="roundRect">
+            <a:avLst>
+              <a:gd name="adj" fmla="val 16000"/>
+            </a:avLst>
+          </a:prstGeom>
+          <a:solidFill>
+            <a:srgbClr val="0FA3A3"/>
+          </a:solidFill>
+          <a:ln/>
+        </p:spPr>
+      </p:sp>
+      <p:sp>
+        <p:nvSpPr>
+          <p:cNvPr id="6" name="Text 4"/>
+          <p:cNvSpPr/>
+          <p:nvPr/>
+        </p:nvSpPr>
+        <p:spPr>
+          <a:xfrm>
+            <a:off x="896112" y="2020824"/>
+            <a:ext cx="914400" cy="457200"/>
+          </a:xfrm>
+          <a:prstGeom prst="rect">
+            <a:avLst/>
+          </a:prstGeom>
+          <a:noFill/>
+          <a:ln/>
+        </p:spPr>
+        <p:txBody>
+          <a:bodyPr wrap="square" lIns="0" tIns="0" rIns="0" bIns="0" rtlCol="0" anchor="ctr"/>
+          <a:lstStyle/>
+          <a:p>
+            <a:pPr algn="ctr" indent="0" marL="0">
+              <a:buNone/>
+            </a:pPr>
+            <a:r>
+              <a:rPr lang="en-US" sz="1600" b="1" dirty="0">
+                <a:solidFill>
+                  <a:srgbClr val="FFFFFF"/>
+                </a:solidFill>
+                <a:latin typeface="Cambria" pitchFamily="34" charset="0"/>
+                <a:ea typeface="Cambria" pitchFamily="34" charset="-122"/>
+                <a:cs typeface="Cambria" pitchFamily="34" charset="-120"/>
+              </a:rPr>
+              <a:t>Q0</a:t>
+            </a:r>
+            <a:endParaRPr lang="en-US" sz="1600" dirty="0"/>
+          </a:p>
+        </p:txBody>
+      </p:sp>
+      <p:sp>
+        <p:nvSpPr>
+          <p:cNvPr id="7" name="Text 5"/>
+          <p:cNvSpPr/>
+          <p:nvPr/>
+        </p:nvSpPr>
+        <p:spPr>
+          <a:xfrm>
+            <a:off x="896112" y="2624328"/>
+            <a:ext cx="2148840" cy="502920"/>
+          </a:xfrm>
+          <a:prstGeom prst="rect">
+            <a:avLst/>
+          </a:prstGeom>
+          <a:noFill/>
+          <a:ln/>
+        </p:spPr>
+        <p:txBody>
+          <a:bodyPr wrap="square" lIns="0" tIns="0" rIns="0" bIns="0" rtlCol="0" anchor="ctr"/>
+          <a:lstStyle/>
+          <a:p>
+            <a:pPr indent="0" marL="0">
+              <a:lnSpc>
+                <a:spcPct val="98000"/>
+              </a:lnSpc>
+              <a:buNone/>
+            </a:pPr>
+            <a:r>
+              <a:rPr lang="en-US" sz="1350" b="1" dirty="0">
+                <a:solidFill>
+                  <a:srgbClr val="17303A"/>
+                </a:solidFill>
+                <a:latin typeface="Calibri" pitchFamily="34" charset="0"/>
+                <a:ea typeface="Calibri" pitchFamily="34" charset="-122"/>
+                <a:cs typeface="Calibri" pitchFamily="34" charset="-120"/>
+              </a:rPr>
+              <a:t>Inrichting</a:t>
+            </a:r>
+            <a:endParaRPr lang="en-US" sz="1350" dirty="0"/>
+          </a:p>
+        </p:txBody>
+      </p:sp>
+      <p:sp>
+        <p:nvSpPr>
+          <p:cNvPr id="8" name="Text 6"/>
+          <p:cNvSpPr/>
+          <p:nvPr/>
+        </p:nvSpPr>
+        <p:spPr>
+          <a:xfrm>
+            <a:off x="896112" y="3154680"/>
+            <a:ext cx="2148840" cy="914400"/>
+          </a:xfrm>
+          <a:prstGeom prst="rect">
+            <a:avLst/>
+          </a:prstGeom>
+          <a:noFill/>
+          <a:ln/>
+        </p:spPr>
+        <p:txBody>
+          <a:bodyPr wrap="square" lIns="0" tIns="0" rIns="0" bIns="0" rtlCol="0" anchor="ctr"/>
+          <a:lstStyle/>
+          <a:p>
+            <a:pPr indent="0" marL="0">
+              <a:lnSpc>
+                <a:spcPct val="103000"/>
+              </a:lnSpc>
+              <a:buNone/>
+            </a:pPr>
+            <a:r>
+              <a:rPr lang="en-US" sz="1070" dirty="0">
+                <a:solidFill>
+                  <a:srgbClr val="5F7B88"/>
+                </a:solidFill>
+                <a:latin typeface="Calibri" pitchFamily="34" charset="0"/>
+                <a:ea typeface="Calibri" pitchFamily="34" charset="-122"/>
+                <a:cs typeface="Calibri" pitchFamily="34" charset="-120"/>
+              </a:rPr>
+              <a:t>Segmenten, varianten, regels, holdout, koppeling, meetopzet. 2–3 weken · €4–6k eenmalig.</a:t>
+            </a:r>
+            <a:endParaRPr lang="en-US" sz="1070" dirty="0"/>
+          </a:p>
+        </p:txBody>
+      </p:sp>
+      <p:sp>
+        <p:nvSpPr>
+          <p:cNvPr id="9" name="Shape 7"/>
+          <p:cNvSpPr/>
+          <p:nvPr/>
+        </p:nvSpPr>
+        <p:spPr>
+          <a:xfrm>
+            <a:off x="3520440" y="1783080"/>
+            <a:ext cx="2624328" cy="2377440"/>
+          </a:xfrm>
+          <a:prstGeom prst="roundRect">
+            <a:avLst>
+              <a:gd name="adj" fmla="val 3462"/>
+            </a:avLst>
+          </a:prstGeom>
+          <a:solidFill>
+            <a:srgbClr val="EDF5F5"/>
+          </a:solidFill>
+          <a:ln/>
+          <a:effectLst>
+            <a:outerShdw sx="100000" sy="100000" kx="0" ky="0" algn="bl" rotWithShape="0" blurRad="76200" dist="25400" dir="5400000">
+              <a:srgbClr val="9FB6B6">
+                <a:alpha val="28000"/>
+              </a:srgbClr>
+            </a:outerShdw>
+          </a:effectLst>
+        </p:spPr>
+      </p:sp>
+      <p:sp>
+        <p:nvSpPr>
+          <p:cNvPr id="10" name="Shape 8"/>
+          <p:cNvSpPr/>
+          <p:nvPr/>
+        </p:nvSpPr>
+        <p:spPr>
+          <a:xfrm>
+            <a:off x="3776472" y="2020824"/>
+            <a:ext cx="914400" cy="457200"/>
+          </a:xfrm>
+          <a:prstGeom prst="roundRect">
+            <a:avLst>
+              <a:gd name="adj" fmla="val 16000"/>
+            </a:avLst>
+          </a:prstGeom>
+          <a:solidFill>
+            <a:srgbClr val="0FA3A3"/>
+          </a:solidFill>
+          <a:ln/>
+        </p:spPr>
+      </p:sp>
+      <p:sp>
+        <p:nvSpPr>
+          <p:cNvPr id="11" name="Text 9"/>
+          <p:cNvSpPr/>
+          <p:nvPr/>
+        </p:nvSpPr>
+        <p:spPr>
+          <a:xfrm>
+            <a:off x="3776472" y="2020824"/>
+            <a:ext cx="914400" cy="457200"/>
+          </a:xfrm>
+          <a:prstGeom prst="rect">
+            <a:avLst/>
+          </a:prstGeom>
+          <a:noFill/>
+          <a:ln/>
+        </p:spPr>
+        <p:txBody>
+          <a:bodyPr wrap="square" lIns="0" tIns="0" rIns="0" bIns="0" rtlCol="0" anchor="ctr"/>
+          <a:lstStyle/>
+          <a:p>
+            <a:pPr algn="ctr" indent="0" marL="0">
+              <a:buNone/>
+            </a:pPr>
+            <a:r>
+              <a:rPr lang="en-US" sz="1600" b="1" dirty="0">
+                <a:solidFill>
+                  <a:srgbClr val="FFFFFF"/>
+                </a:solidFill>
+                <a:latin typeface="Cambria" pitchFamily="34" charset="0"/>
+                <a:ea typeface="Cambria" pitchFamily="34" charset="-122"/>
+                <a:cs typeface="Cambria" pitchFamily="34" charset="-120"/>
+              </a:rPr>
+              <a:t>Q1</a:t>
+            </a:r>
+            <a:endParaRPr lang="en-US" sz="1600" dirty="0"/>
+          </a:p>
+        </p:txBody>
+      </p:sp>
+      <p:sp>
+        <p:nvSpPr>
+          <p:cNvPr id="12" name="Text 10"/>
+          <p:cNvSpPr/>
+          <p:nvPr/>
+        </p:nvSpPr>
+        <p:spPr>
+          <a:xfrm>
+            <a:off x="3776472" y="2624328"/>
+            <a:ext cx="2148840" cy="502920"/>
+          </a:xfrm>
+          <a:prstGeom prst="rect">
+            <a:avLst/>
+          </a:prstGeom>
+          <a:noFill/>
+          <a:ln/>
+        </p:spPr>
+        <p:txBody>
+          <a:bodyPr wrap="square" lIns="0" tIns="0" rIns="0" bIns="0" rtlCol="0" anchor="ctr"/>
+          <a:lstStyle/>
+          <a:p>
+            <a:pPr indent="0" marL="0">
+              <a:lnSpc>
+                <a:spcPct val="98000"/>
+              </a:lnSpc>
+              <a:buNone/>
+            </a:pPr>
+            <a:r>
+              <a:rPr lang="en-US" sz="1350" b="1" dirty="0">
+                <a:solidFill>
+                  <a:srgbClr val="17303A"/>
+                </a:solidFill>
+                <a:latin typeface="Calibri" pitchFamily="34" charset="0"/>
+                <a:ea typeface="Calibri" pitchFamily="34" charset="-122"/>
+                <a:cs typeface="Calibri" pitchFamily="34" charset="-120"/>
+              </a:rPr>
+              <a:t>Het loopt, je weet nog niets</a:t>
+            </a:r>
+            <a:endParaRPr lang="en-US" sz="1350" dirty="0"/>
+          </a:p>
+        </p:txBody>
+      </p:sp>
+      <p:sp>
+        <p:nvSpPr>
+          <p:cNvPr id="13" name="Text 11"/>
+          <p:cNvSpPr/>
+          <p:nvPr/>
+        </p:nvSpPr>
+        <p:spPr>
+          <a:xfrm>
+            <a:off x="3776472" y="3154680"/>
+            <a:ext cx="2148840" cy="914400"/>
+          </a:xfrm>
+          <a:prstGeom prst="rect">
+            <a:avLst/>
+          </a:prstGeom>
+          <a:noFill/>
+          <a:ln/>
+        </p:spPr>
+        <p:txBody>
+          <a:bodyPr wrap="square" lIns="0" tIns="0" rIns="0" bIns="0" rtlCol="0" anchor="ctr"/>
+          <a:lstStyle/>
+          <a:p>
+            <a:pPr indent="0" marL="0">
+              <a:lnSpc>
+                <a:spcPct val="103000"/>
+              </a:lnSpc>
+              <a:buNone/>
+            </a:pPr>
+            <a:r>
+              <a:rPr lang="en-US" sz="1070" dirty="0">
+                <a:solidFill>
+                  <a:srgbClr val="5F7B88"/>
+                </a:solidFill>
+                <a:latin typeface="Calibri" pitchFamily="34" charset="0"/>
+                <a:ea typeface="Calibri" pitchFamily="34" charset="-122"/>
+                <a:cs typeface="Calibri" pitchFamily="34" charset="-120"/>
+              </a:rPr>
+              <a:t>Bijstellen: drempels te ruim/krap, lege segmenten, te brede condities. Eerste campagne = eerste toets. Uitkomst: klopt de verkeersverdeling? Nog geen effect.</a:t>
+            </a:r>
+            <a:endParaRPr lang="en-US" sz="1070" dirty="0"/>
+          </a:p>
+        </p:txBody>
+      </p:sp>
+      <p:sp>
+        <p:nvSpPr>
+          <p:cNvPr id="14" name="Shape 12"/>
+          <p:cNvSpPr/>
+          <p:nvPr/>
+        </p:nvSpPr>
+        <p:spPr>
+          <a:xfrm>
+            <a:off x="6400800" y="1783080"/>
+            <a:ext cx="2624328" cy="2377440"/>
+          </a:xfrm>
+          <a:prstGeom prst="roundRect">
+            <a:avLst>
+              <a:gd name="adj" fmla="val 3462"/>
+            </a:avLst>
+          </a:prstGeom>
+          <a:solidFill>
+            <a:srgbClr val="EDF5F5"/>
+          </a:solidFill>
+          <a:ln/>
+          <a:effectLst>
+            <a:outerShdw sx="100000" sy="100000" kx="0" ky="0" algn="bl" rotWithShape="0" blurRad="76200" dist="25400" dir="5400000">
+              <a:srgbClr val="9FB6B6">
+                <a:alpha val="28000"/>
+              </a:srgbClr>
+            </a:outerShdw>
+          </a:effectLst>
+        </p:spPr>
+      </p:sp>
+      <p:sp>
+        <p:nvSpPr>
+          <p:cNvPr id="15" name="Shape 13"/>
+          <p:cNvSpPr/>
+          <p:nvPr/>
+        </p:nvSpPr>
+        <p:spPr>
+          <a:xfrm>
+            <a:off x="6656832" y="2020824"/>
+            <a:ext cx="914400" cy="457200"/>
+          </a:xfrm>
+          <a:prstGeom prst="roundRect">
+            <a:avLst>
+              <a:gd name="adj" fmla="val 16000"/>
+            </a:avLst>
+          </a:prstGeom>
+          <a:solidFill>
+            <a:srgbClr val="0FA3A3"/>
+          </a:solidFill>
+          <a:ln/>
+        </p:spPr>
+      </p:sp>
+      <p:sp>
+        <p:nvSpPr>
+          <p:cNvPr id="16" name="Text 14"/>
+          <p:cNvSpPr/>
+          <p:nvPr/>
+        </p:nvSpPr>
+        <p:spPr>
+          <a:xfrm>
+            <a:off x="6656832" y="2020824"/>
+            <a:ext cx="914400" cy="457200"/>
+          </a:xfrm>
+          <a:prstGeom prst="rect">
+            <a:avLst/>
+          </a:prstGeom>
+          <a:noFill/>
+          <a:ln/>
+        </p:spPr>
+        <p:txBody>
+          <a:bodyPr wrap="square" lIns="0" tIns="0" rIns="0" bIns="0" rtlCol="0" anchor="ctr"/>
+          <a:lstStyle/>
+          <a:p>
+            <a:pPr algn="ctr" indent="0" marL="0">
+              <a:buNone/>
+            </a:pPr>
+            <a:r>
+              <a:rPr lang="en-US" sz="1600" b="1" dirty="0">
+                <a:solidFill>
+                  <a:srgbClr val="FFFFFF"/>
+                </a:solidFill>
+                <a:latin typeface="Cambria" pitchFamily="34" charset="0"/>
+                <a:ea typeface="Cambria" pitchFamily="34" charset="-122"/>
+                <a:cs typeface="Cambria" pitchFamily="34" charset="-120"/>
+              </a:rPr>
+              <a:t>Q2</a:t>
+            </a:r>
+            <a:endParaRPr lang="en-US" sz="1600" dirty="0"/>
+          </a:p>
+        </p:txBody>
+      </p:sp>
+      <p:sp>
+        <p:nvSpPr>
+          <p:cNvPr id="17" name="Text 15"/>
+          <p:cNvSpPr/>
+          <p:nvPr/>
+        </p:nvSpPr>
+        <p:spPr>
+          <a:xfrm>
+            <a:off x="6656832" y="2624328"/>
+            <a:ext cx="2148840" cy="502920"/>
+          </a:xfrm>
+          <a:prstGeom prst="rect">
+            <a:avLst/>
+          </a:prstGeom>
+          <a:noFill/>
+          <a:ln/>
+        </p:spPr>
+        <p:txBody>
+          <a:bodyPr wrap="square" lIns="0" tIns="0" rIns="0" bIns="0" rtlCol="0" anchor="ctr"/>
+          <a:lstStyle/>
+          <a:p>
+            <a:pPr indent="0" marL="0">
+              <a:lnSpc>
+                <a:spcPct val="98000"/>
+              </a:lnSpc>
+              <a:buNone/>
+            </a:pPr>
+            <a:r>
+              <a:rPr lang="en-US" sz="1350" b="1" dirty="0">
+                <a:solidFill>
+                  <a:srgbClr val="17303A"/>
+                </a:solidFill>
+                <a:latin typeface="Calibri" pitchFamily="34" charset="0"/>
+                <a:ea typeface="Calibri" pitchFamily="34" charset="-122"/>
+                <a:cs typeface="Calibri" pitchFamily="34" charset="-120"/>
+              </a:rPr>
+              <a:t>Halfjaarpunt</a:t>
+            </a:r>
+            <a:endParaRPr lang="en-US" sz="1350" dirty="0"/>
+          </a:p>
+        </p:txBody>
+      </p:sp>
+      <p:sp>
+        <p:nvSpPr>
+          <p:cNvPr id="18" name="Text 16"/>
+          <p:cNvSpPr/>
+          <p:nvPr/>
+        </p:nvSpPr>
+        <p:spPr>
+          <a:xfrm>
+            <a:off x="6656832" y="3154680"/>
+            <a:ext cx="2148840" cy="914400"/>
+          </a:xfrm>
+          <a:prstGeom prst="rect">
+            <a:avLst/>
+          </a:prstGeom>
+          <a:noFill/>
+          <a:ln/>
+        </p:spPr>
+        <p:txBody>
+          <a:bodyPr wrap="square" lIns="0" tIns="0" rIns="0" bIns="0" rtlCol="0" anchor="ctr"/>
+          <a:lstStyle/>
+          <a:p>
+            <a:pPr indent="0" marL="0">
+              <a:lnSpc>
+                <a:spcPct val="103000"/>
+              </a:lnSpc>
+              <a:buNone/>
+            </a:pPr>
+            <a:r>
+              <a:rPr lang="en-US" sz="1070" dirty="0">
+                <a:solidFill>
+                  <a:srgbClr val="5F7B88"/>
+                </a:solidFill>
+                <a:latin typeface="Calibri" pitchFamily="34" charset="0"/>
+                <a:ea typeface="Calibri" pitchFamily="34" charset="-122"/>
+                <a:cs typeface="Calibri" pitchFamily="34" charset="-120"/>
+              </a:rPr>
+              <a:t>Zwakke varianten eruit; holdout geeft richting, nog geen cijfer. Eerlijk: bij weinig B2B-verkeer is een half jaar vaak te kort voor een hard antwoord.</a:t>
+            </a:r>
+            <a:endParaRPr lang="en-US" sz="1070" dirty="0"/>
+          </a:p>
+        </p:txBody>
+      </p:sp>
+      <p:sp>
+        <p:nvSpPr>
+          <p:cNvPr id="19" name="Shape 17"/>
+          <p:cNvSpPr/>
+          <p:nvPr/>
+        </p:nvSpPr>
+        <p:spPr>
+          <a:xfrm>
+            <a:off x="9281160" y="1783080"/>
+            <a:ext cx="2624328" cy="2377440"/>
+          </a:xfrm>
+          <a:prstGeom prst="roundRect">
+            <a:avLst>
+              <a:gd name="adj" fmla="val 3462"/>
+            </a:avLst>
+          </a:prstGeom>
+          <a:solidFill>
+            <a:srgbClr val="E4F5F1"/>
+          </a:solidFill>
+          <a:ln/>
+          <a:effectLst>
+            <a:outerShdw sx="100000" sy="100000" kx="0" ky="0" algn="bl" rotWithShape="0" blurRad="76200" dist="25400" dir="5400000">
+              <a:srgbClr val="9FB6B6">
+                <a:alpha val="28000"/>
+              </a:srgbClr>
+            </a:outerShdw>
+          </a:effectLst>
+        </p:spPr>
+      </p:sp>
+      <p:sp>
+        <p:nvSpPr>
+          <p:cNvPr id="20" name="Shape 18"/>
+          <p:cNvSpPr/>
+          <p:nvPr/>
+        </p:nvSpPr>
+        <p:spPr>
+          <a:xfrm>
+            <a:off x="9537192" y="2020824"/>
+            <a:ext cx="914400" cy="457200"/>
+          </a:xfrm>
+          <a:prstGeom prst="roundRect">
+            <a:avLst>
+              <a:gd name="adj" fmla="val 16000"/>
+            </a:avLst>
+          </a:prstGeom>
+          <a:solidFill>
+            <a:srgbClr val="17C3B2"/>
+          </a:solidFill>
+          <a:ln/>
+        </p:spPr>
+      </p:sp>
+      <p:sp>
+        <p:nvSpPr>
+          <p:cNvPr id="21" name="Text 19"/>
+          <p:cNvSpPr/>
+          <p:nvPr/>
+        </p:nvSpPr>
+        <p:spPr>
+          <a:xfrm>
+            <a:off x="9537192" y="2020824"/>
+            <a:ext cx="914400" cy="457200"/>
+          </a:xfrm>
+          <a:prstGeom prst="rect">
+            <a:avLst/>
+          </a:prstGeom>
+          <a:noFill/>
+          <a:ln/>
+        </p:spPr>
+        <p:txBody>
+          <a:bodyPr wrap="square" lIns="0" tIns="0" rIns="0" bIns="0" rtlCol="0" anchor="ctr"/>
+          <a:lstStyle/>
+          <a:p>
+            <a:pPr algn="ctr" indent="0" marL="0">
+              <a:buNone/>
+            </a:pPr>
+            <a:r>
+              <a:rPr lang="en-US" sz="1600" b="1" dirty="0">
+                <a:solidFill>
+                  <a:srgbClr val="FFFFFF"/>
+                </a:solidFill>
+                <a:latin typeface="Cambria" pitchFamily="34" charset="0"/>
+                <a:ea typeface="Cambria" pitchFamily="34" charset="-122"/>
+                <a:cs typeface="Cambria" pitchFamily="34" charset="-120"/>
+              </a:rPr>
+              <a:t>Q3–4</a:t>
+            </a:r>
+            <a:endParaRPr lang="en-US" sz="1600" dirty="0"/>
+          </a:p>
+        </p:txBody>
+      </p:sp>
+      <p:sp>
+        <p:nvSpPr>
+          <p:cNvPr id="22" name="Text 20"/>
+          <p:cNvSpPr/>
+          <p:nvPr/>
+        </p:nvSpPr>
+        <p:spPr>
+          <a:xfrm>
+            <a:off x="9537192" y="2624328"/>
+            <a:ext cx="2148840" cy="502920"/>
+          </a:xfrm>
+          <a:prstGeom prst="rect">
+            <a:avLst/>
+          </a:prstGeom>
+          <a:noFill/>
+          <a:ln/>
+        </p:spPr>
+        <p:txBody>
+          <a:bodyPr wrap="square" lIns="0" tIns="0" rIns="0" bIns="0" rtlCol="0" anchor="ctr"/>
+          <a:lstStyle/>
+          <a:p>
+            <a:pPr indent="0" marL="0">
+              <a:lnSpc>
+                <a:spcPct val="98000"/>
+              </a:lnSpc>
+              <a:buNone/>
+            </a:pPr>
+            <a:r>
+              <a:rPr lang="en-US" sz="1350" b="1" dirty="0">
+                <a:solidFill>
+                  <a:srgbClr val="17303A"/>
+                </a:solidFill>
+                <a:latin typeface="Calibri" pitchFamily="34" charset="0"/>
+                <a:ea typeface="Calibri" pitchFamily="34" charset="-122"/>
+                <a:cs typeface="Calibri" pitchFamily="34" charset="-120"/>
+              </a:rPr>
+              <a:t>Het rendement</a:t>
+            </a:r>
+            <a:endParaRPr lang="en-US" sz="1350" dirty="0"/>
+          </a:p>
+        </p:txBody>
+      </p:sp>
+      <p:sp>
+        <p:nvSpPr>
+          <p:cNvPr id="23" name="Text 21"/>
+          <p:cNvSpPr/>
+          <p:nvPr/>
+        </p:nvSpPr>
+        <p:spPr>
+          <a:xfrm>
+            <a:off x="9537192" y="3154680"/>
+            <a:ext cx="2148840" cy="914400"/>
+          </a:xfrm>
+          <a:prstGeom prst="rect">
+            <a:avLst/>
+          </a:prstGeom>
+          <a:noFill/>
+          <a:ln/>
+        </p:spPr>
+        <p:txBody>
+          <a:bodyPr wrap="square" lIns="0" tIns="0" rIns="0" bIns="0" rtlCol="0" anchor="ctr"/>
+          <a:lstStyle/>
+          <a:p>
+            <a:pPr indent="0" marL="0">
+              <a:lnSpc>
+                <a:spcPct val="103000"/>
+              </a:lnSpc>
+              <a:buNone/>
+            </a:pPr>
+            <a:r>
+              <a:rPr lang="en-US" sz="1070" dirty="0">
+                <a:solidFill>
+                  <a:srgbClr val="5F7B88"/>
+                </a:solidFill>
+                <a:latin typeface="Calibri" pitchFamily="34" charset="0"/>
+                <a:ea typeface="Calibri" pitchFamily="34" charset="-122"/>
+                <a:cs typeface="Calibri" pitchFamily="34" charset="-120"/>
+              </a:rPr>
+              <a:t>Segmentatie gecorrigeerd, zwakke varianten weg, holdout genoeg gedraaid. Jaargesprek: wat deed het, wat nu nog winnen.</a:t>
+            </a:r>
+            <a:endParaRPr lang="en-US" sz="1070" dirty="0"/>
+          </a:p>
+        </p:txBody>
+      </p:sp>
+      <p:sp>
+        <p:nvSpPr>
+          <p:cNvPr id="24" name="Shape 22"/>
+          <p:cNvSpPr/>
+          <p:nvPr/>
+        </p:nvSpPr>
+        <p:spPr>
+          <a:xfrm>
+            <a:off x="640080" y="4434840"/>
+            <a:ext cx="10881360" cy="1005840"/>
+          </a:xfrm>
+          <a:prstGeom prst="roundRect">
+            <a:avLst>
+              <a:gd name="adj" fmla="val 8182"/>
+            </a:avLst>
+          </a:prstGeom>
+          <a:solidFill>
+            <a:srgbClr val="0E2A38"/>
+          </a:solidFill>
+          <a:ln/>
+        </p:spPr>
+      </p:sp>
+      <p:sp>
+        <p:nvSpPr>
+          <p:cNvPr id="25" name="Text 23"/>
+          <p:cNvSpPr/>
+          <p:nvPr/>
+        </p:nvSpPr>
+        <p:spPr>
+          <a:xfrm>
+            <a:off x="960120" y="4434840"/>
+            <a:ext cx="10241280" cy="1005840"/>
+          </a:xfrm>
+          <a:prstGeom prst="rect">
+            <a:avLst/>
+          </a:prstGeom>
+          <a:noFill/>
+          <a:ln/>
+        </p:spPr>
+        <p:txBody>
+          <a:bodyPr wrap="square" lIns="0" tIns="0" rIns="0" bIns="0" rtlCol="0" anchor="ctr"/>
+          <a:lstStyle/>
+          <a:p>
+            <a:pPr indent="0" marL="0">
+              <a:lnSpc>
+                <a:spcPct val="108000"/>
+              </a:lnSpc>
+              <a:buNone/>
+            </a:pPr>
+            <a:r>
+              <a:rPr lang="en-US" sz="1350" b="1" dirty="0">
+                <a:solidFill>
+                  <a:srgbClr val="17C3B2"/>
+                </a:solidFill>
+                <a:latin typeface="Calibri" pitchFamily="34" charset="0"/>
+                <a:ea typeface="Calibri" pitchFamily="34" charset="-122"/>
+                <a:cs typeface="Calibri" pitchFamily="34" charset="-120"/>
+              </a:rPr>
+              <a:t>Verkoop geen half jaar. </a:t>
+            </a:r>
+            <a:pPr indent="0" marL="0">
+              <a:lnSpc>
+                <a:spcPct val="108000"/>
+              </a:lnSpc>
+              <a:buNone/>
+            </a:pPr>
+            <a:r>
+              <a:rPr lang="en-US" sz="1350" dirty="0">
+                <a:solidFill>
+                  <a:srgbClr val="FFFFFF"/>
+                </a:solidFill>
+                <a:latin typeface="Calibri" pitchFamily="34" charset="0"/>
+                <a:ea typeface="Calibri" pitchFamily="34" charset="-122"/>
+                <a:cs typeface="Calibri" pitchFamily="34" charset="-120"/>
+              </a:rPr>
+              <a:t>Dat eindigt precies waar je nog geen antwoord hebt. Verkoop een jaar met een uitstapmoment na zes maanden — dat verlaagt de drempel én geeft het instrument de tijd die het nodig heeft.</a:t>
+            </a:r>
+            <a:endParaRPr lang="en-US" sz="1350" dirty="0"/>
+          </a:p>
+        </p:txBody>
+      </p:sp>
+      <p:sp>
+        <p:nvSpPr>
+          <p:cNvPr id="26" name="Text 24"/>
+          <p:cNvSpPr/>
+          <p:nvPr/>
+        </p:nvSpPr>
+        <p:spPr>
+          <a:xfrm>
+            <a:off x="640080" y="5623560"/>
+            <a:ext cx="10972800" cy="365760"/>
+          </a:xfrm>
+          <a:prstGeom prst="rect">
+            <a:avLst/>
+          </a:prstGeom>
+          <a:noFill/>
+          <a:ln/>
+        </p:spPr>
+        <p:txBody>
+          <a:bodyPr wrap="square" lIns="0" tIns="0" rIns="0" bIns="0" rtlCol="0" anchor="ctr"/>
+          <a:lstStyle/>
+          <a:p>
+            <a:pPr indent="0" marL="0">
+              <a:buNone/>
+            </a:pPr>
+            <a:r>
+              <a:rPr lang="en-US" sz="1250" b="1" i="1" dirty="0">
+                <a:solidFill>
+                  <a:srgbClr val="0FA3A3"/>
+                </a:solidFill>
+                <a:latin typeface="Calibri" pitchFamily="34" charset="0"/>
+                <a:ea typeface="Calibri" pitchFamily="34" charset="-122"/>
+                <a:cs typeface="Calibri" pitchFamily="34" charset="-120"/>
+              </a:rPr>
+              <a:t>Horizon (setup + retainer): half jaar ≈ €13–20k · jaar ≈ €22–35k, afhankelijk van het maandtarief.</a:t>
+            </a:r>
+            <a:endParaRPr lang="en-US" sz="1250" dirty="0"/>
+          </a:p>
+        </p:txBody>
+      </p:sp>
+    </p:spTree>
+  </p:cSld>
+  <p:clrMapOvr>
+    <a:masterClrMapping/>
+  </p:clrMapOvr>
+</p:sld>
+</file>
+
+<file path=ppt/slides/slide17.xml><?xml version="1.0" encoding="utf-8"?>
+<p:sld xmlns:a="http://schemas.openxmlformats.org/drawingml/2006/main" xmlns:r="http://schemas.openxmlformats.org/officeDocument/2006/relationships" xmlns:p="http://schemas.openxmlformats.org/presentationml/2006/main">
+  <p:cSld name="Slide 17">
+    <p:bg>
+      <p:bgPr>
+        <a:solidFill>
           <a:srgbClr val="0E2A38"/>
         </a:solidFill>
       </p:bgPr>
@@ -8226,9 +9241,9 @@
 </p:sld>
 </file>
 
-<file path=ppt/slides/slide17.xml><?xml version="1.0" encoding="utf-8"?>
+<file path=ppt/slides/slide18.xml><?xml version="1.0" encoding="utf-8"?>
 <p:sld xmlns:a="http://schemas.openxmlformats.org/drawingml/2006/main" xmlns:r="http://schemas.openxmlformats.org/officeDocument/2006/relationships" xmlns:p="http://schemas.openxmlformats.org/presentationml/2006/main">
-  <p:cSld name="Slide 17">
+  <p:cSld name="Slide 18">
     <p:bg>
       <p:bgPr>
         <a:solidFill>

</xml_diff>

<commit_message>
docs: deck bijgewerkt (tweeluik-demo-slide + kameleon-metafoor op 'Ons antwoord') + verkoopvoorstel met 'Wat we doen'-sectie
</commit_message>
<xml_diff>
--- a/docs/mister-chameleon-demo.pptx
+++ b/docs/mister-chameleon-demo.pptx
@@ -8431,7 +8431,7 @@
     <p:bg>
       <p:bgPr>
         <a:solidFill>
-          <a:srgbClr val="0E2A38"/>
+          <a:srgbClr val="FFFFFF"/>
         </a:solidFill>
       </p:bgPr>
     </p:bg>
@@ -8457,34 +8457,34 @@
         </p:nvSpPr>
         <p:spPr>
           <a:xfrm>
-            <a:off x="822960" y="2194560"/>
-            <a:ext cx="3657600" cy="822960"/>
-          </a:xfrm>
-          <a:prstGeom prst="rect">
-            <a:avLst/>
-          </a:prstGeom>
-          <a:noFill/>
-          <a:ln/>
-        </p:spPr>
-        <p:txBody>
-          <a:bodyPr wrap="square" lIns="0" tIns="0" rIns="0" bIns="0" rtlCol="0" anchor="ctr"/>
-          <a:lstStyle/>
-          <a:p>
-            <a:pPr indent="0" marL="0">
-              <a:buNone/>
-            </a:pPr>
-            <a:r>
-              <a:rPr lang="en-US" sz="6400" b="1" dirty="0">
-                <a:solidFill>
-                  <a:srgbClr val="0FA3A3"/>
+            <a:off x="640080" y="457200"/>
+            <a:ext cx="10972800" cy="731520"/>
+          </a:xfrm>
+          <a:prstGeom prst="rect">
+            <a:avLst/>
+          </a:prstGeom>
+          <a:noFill/>
+          <a:ln/>
+        </p:spPr>
+        <p:txBody>
+          <a:bodyPr wrap="square" lIns="0" tIns="0" rIns="0" bIns="0" rtlCol="0" anchor="ctr"/>
+          <a:lstStyle/>
+          <a:p>
+            <a:pPr indent="0" marL="0">
+              <a:buNone/>
+            </a:pPr>
+            <a:r>
+              <a:rPr lang="en-US" sz="3000" b="1" dirty="0">
+                <a:solidFill>
+                  <a:srgbClr val="17303A"/>
                 </a:solidFill>
                 <a:latin typeface="Cambria" pitchFamily="34" charset="0"/>
                 <a:ea typeface="Cambria" pitchFamily="34" charset="-122"/>
                 <a:cs typeface="Cambria" pitchFamily="34" charset="-120"/>
               </a:rPr>
-              <a:t>Demo</a:t>
-            </a:r>
-            <a:endParaRPr lang="en-US" sz="6400" dirty="0"/>
+              <a:t>De demo — twee losse demo's</a:t>
+            </a:r>
+            <a:endParaRPr lang="en-US" sz="3000" dirty="0"/>
           </a:p>
         </p:txBody>
       </p:sp>
@@ -8496,97 +8496,55 @@
         </p:nvSpPr>
         <p:spPr>
           <a:xfrm>
-            <a:off x="822960" y="3154680"/>
-            <a:ext cx="10424160" cy="1097280"/>
-          </a:xfrm>
-          <a:prstGeom prst="rect">
-            <a:avLst/>
-          </a:prstGeom>
-          <a:noFill/>
-          <a:ln/>
-        </p:spPr>
-        <p:txBody>
-          <a:bodyPr wrap="square" lIns="0" tIns="0" rIns="0" bIns="0" rtlCol="0" anchor="ctr"/>
-          <a:lstStyle/>
-          <a:p>
-            <a:pPr indent="0" marL="0">
-              <a:buNone/>
-            </a:pPr>
-            <a:r>
-              <a:rPr lang="en-US" sz="3800" b="1" dirty="0">
-                <a:solidFill>
-                  <a:srgbClr val="FFFFFF"/>
-                </a:solidFill>
-                <a:latin typeface="Cambria" pitchFamily="34" charset="0"/>
-                <a:ea typeface="Cambria" pitchFamily="34" charset="-122"/>
-                <a:cs typeface="Cambria" pitchFamily="34" charset="-120"/>
-              </a:rPr>
-              <a:t>Vier bezoekers, één site</a:t>
-            </a:r>
-            <a:endParaRPr lang="en-US" sz="3800" dirty="0"/>
-          </a:p>
-        </p:txBody>
-      </p:sp>
-      <p:sp>
-        <p:nvSpPr>
-          <p:cNvPr id="4" name="Text 2"/>
-          <p:cNvSpPr/>
-          <p:nvPr/>
-        </p:nvSpPr>
-        <p:spPr>
-          <a:xfrm>
-            <a:off x="868680" y="4297680"/>
-            <a:ext cx="9875520" cy="1005840"/>
-          </a:xfrm>
-          <a:prstGeom prst="rect">
-            <a:avLst/>
-          </a:prstGeom>
-          <a:noFill/>
-          <a:ln/>
-        </p:spPr>
-        <p:txBody>
-          <a:bodyPr wrap="square" lIns="0" tIns="0" rIns="0" bIns="0" rtlCol="0" anchor="ctr"/>
-          <a:lstStyle/>
-          <a:p>
-            <a:pPr indent="0" marL="0">
-              <a:lnSpc>
-                <a:spcPct val="110000"/>
-              </a:lnSpc>
-              <a:buNone/>
-            </a:pPr>
-            <a:r>
-              <a:rPr lang="en-US" sz="1700" dirty="0">
-                <a:solidFill>
-                  <a:srgbClr val="CFE8E6"/>
-                </a:solidFill>
-                <a:latin typeface="Calibri" pitchFamily="34" charset="0"/>
-                <a:ea typeface="Calibri" pitchFamily="34" charset="-122"/>
-                <a:cs typeface="Calibri" pitchFamily="34" charset="-120"/>
-              </a:rPr>
-              <a:t>Kies een persona in het Scenario Control Panel, ververs, en benoem wat er verandert. Volledig draaiboek: docs/demo-draaiboek.md.</a:t>
-            </a:r>
-            <a:endParaRPr lang="en-US" sz="1700" dirty="0"/>
-          </a:p>
-        </p:txBody>
-      </p:sp>
-      <p:sp>
-        <p:nvSpPr>
-          <p:cNvPr id="5" name="Shape 3"/>
-          <p:cNvSpPr/>
-          <p:nvPr/>
-        </p:nvSpPr>
-        <p:spPr>
-          <a:xfrm>
-            <a:off x="822960" y="5029200"/>
-            <a:ext cx="2606040" cy="1188720"/>
+            <a:off x="658368" y="1115568"/>
+            <a:ext cx="10972800" cy="457200"/>
+          </a:xfrm>
+          <a:prstGeom prst="rect">
+            <a:avLst/>
+          </a:prstGeom>
+          <a:noFill/>
+          <a:ln/>
+        </p:spPr>
+        <p:txBody>
+          <a:bodyPr wrap="square" lIns="0" tIns="0" rIns="0" bIns="0" rtlCol="0" anchor="ctr"/>
+          <a:lstStyle/>
+          <a:p>
+            <a:pPr indent="0" marL="0">
+              <a:buNone/>
+            </a:pPr>
+            <a:r>
+              <a:rPr lang="en-US" sz="1500" dirty="0">
+                <a:solidFill>
+                  <a:srgbClr val="5F7B88"/>
+                </a:solidFill>
+                <a:latin typeface="Calibri" pitchFamily="34" charset="0"/>
+                <a:ea typeface="Calibri" pitchFamily="34" charset="-122"/>
+                <a:cs typeface="Calibri" pitchFamily="34" charset="-120"/>
+              </a:rPr>
+              <a:t>De prospect klikt zelf; jij geeft de schakelaar uit handen. Draaiboek: docs/demo-draaiboek.md.</a:t>
+            </a:r>
+            <a:endParaRPr lang="en-US" sz="1500" dirty="0"/>
+          </a:p>
+        </p:txBody>
+      </p:sp>
+      <p:sp>
+        <p:nvSpPr>
+          <p:cNvPr id="4" name="Shape 2"/>
+          <p:cNvSpPr/>
+          <p:nvPr/>
+        </p:nvSpPr>
+        <p:spPr>
+          <a:xfrm>
+            <a:off x="640080" y="1783080"/>
+            <a:ext cx="5349240" cy="3429000"/>
           </a:xfrm>
           <a:prstGeom prst="roundRect">
             <a:avLst>
-              <a:gd name="adj" fmla="val 6923"/>
+              <a:gd name="adj" fmla="val 2400"/>
             </a:avLst>
           </a:prstGeom>
           <a:solidFill>
-            <a:srgbClr val="12414E"/>
+            <a:srgbClr val="EDF5F5"/>
           </a:solidFill>
           <a:ln/>
           <a:effectLst>
@@ -8600,159 +8558,242 @@
       </p:sp>
       <p:sp>
         <p:nvSpPr>
-          <p:cNvPr id="6" name="Shape 4"/>
-          <p:cNvSpPr/>
-          <p:nvPr/>
-        </p:nvSpPr>
-        <p:spPr>
-          <a:xfrm>
-            <a:off x="1051560" y="5257800"/>
-            <a:ext cx="457200" cy="457200"/>
-          </a:xfrm>
-          <a:prstGeom prst="ellipse">
-            <a:avLst/>
-          </a:prstGeom>
-          <a:solidFill>
-            <a:srgbClr val="17C3B2"/>
-          </a:solidFill>
-          <a:ln/>
-        </p:spPr>
-      </p:sp>
-      <p:sp>
-        <p:nvSpPr>
-          <p:cNvPr id="7" name="Text 5"/>
-          <p:cNvSpPr/>
-          <p:nvPr/>
-        </p:nvSpPr>
-        <p:spPr>
-          <a:xfrm>
-            <a:off x="1051560" y="5257800"/>
-            <a:ext cx="457200" cy="457200"/>
-          </a:xfrm>
-          <a:prstGeom prst="rect">
-            <a:avLst/>
-          </a:prstGeom>
-          <a:noFill/>
-          <a:ln/>
-        </p:spPr>
-        <p:txBody>
-          <a:bodyPr wrap="square" lIns="0" tIns="0" rIns="0" bIns="0" rtlCol="0" anchor="ctr"/>
-          <a:lstStyle/>
-          <a:p>
-            <a:pPr algn="ctr" indent="0" marL="0">
-              <a:buNone/>
-            </a:pPr>
-            <a:r>
-              <a:rPr lang="en-US" sz="1500" b="1" dirty="0">
-                <a:solidFill>
-                  <a:srgbClr val="FFFFFF"/>
+          <p:cNvPr id="5" name="Text 3"/>
+          <p:cNvSpPr/>
+          <p:nvPr/>
+        </p:nvSpPr>
+        <p:spPr>
+          <a:xfrm>
+            <a:off x="932688" y="2002536"/>
+            <a:ext cx="4764024" cy="365760"/>
+          </a:xfrm>
+          <a:prstGeom prst="rect">
+            <a:avLst/>
+          </a:prstGeom>
+          <a:noFill/>
+          <a:ln/>
+        </p:spPr>
+        <p:txBody>
+          <a:bodyPr wrap="square" lIns="0" tIns="0" rIns="0" bIns="0" rtlCol="0" anchor="ctr"/>
+          <a:lstStyle/>
+          <a:p>
+            <a:pPr indent="0" marL="0">
+              <a:buNone/>
+            </a:pPr>
+            <a:r>
+              <a:rPr lang="en-US" sz="1900" b="1" dirty="0">
+                <a:solidFill>
+                  <a:srgbClr val="17303A"/>
                 </a:solidFill>
                 <a:latin typeface="Cambria" pitchFamily="34" charset="0"/>
                 <a:ea typeface="Cambria" pitchFamily="34" charset="-122"/>
                 <a:cs typeface="Cambria" pitchFamily="34" charset="-120"/>
               </a:rPr>
-              <a:t>1</a:t>
-            </a:r>
-            <a:endParaRPr lang="en-US" sz="1500" dirty="0"/>
-          </a:p>
-        </p:txBody>
-      </p:sp>
-      <p:sp>
-        <p:nvSpPr>
-          <p:cNvPr id="8" name="Text 6"/>
-          <p:cNvSpPr/>
-          <p:nvPr/>
-        </p:nvSpPr>
-        <p:spPr>
-          <a:xfrm>
-            <a:off x="1645920" y="5212080"/>
-            <a:ext cx="1691640" cy="365760"/>
-          </a:xfrm>
-          <a:prstGeom prst="rect">
-            <a:avLst/>
-          </a:prstGeom>
-          <a:noFill/>
-          <a:ln/>
-        </p:spPr>
-        <p:txBody>
-          <a:bodyPr wrap="square" lIns="0" tIns="0" rIns="0" bIns="0" rtlCol="0" anchor="ctr"/>
-          <a:lstStyle/>
-          <a:p>
-            <a:pPr indent="0" marL="0">
-              <a:buNone/>
-            </a:pPr>
-            <a:r>
-              <a:rPr lang="en-US" sz="1400" b="1" dirty="0">
-                <a:solidFill>
-                  <a:srgbClr val="FFFFFF"/>
-                </a:solidFill>
-                <a:latin typeface="Calibri" pitchFamily="34" charset="0"/>
-                <a:ea typeface="Calibri" pitchFamily="34" charset="-122"/>
-                <a:cs typeface="Calibri" pitchFamily="34" charset="-120"/>
-              </a:rPr>
-              <a:t>Inkoper</a:t>
-            </a:r>
-            <a:endParaRPr lang="en-US" sz="1400" dirty="0"/>
-          </a:p>
-        </p:txBody>
-      </p:sp>
-      <p:sp>
-        <p:nvSpPr>
-          <p:cNvPr id="9" name="Text 7"/>
-          <p:cNvSpPr/>
-          <p:nvPr/>
-        </p:nvSpPr>
-        <p:spPr>
-          <a:xfrm>
-            <a:off x="1078992" y="5742432"/>
-            <a:ext cx="2194560" cy="365760"/>
-          </a:xfrm>
-          <a:prstGeom prst="rect">
-            <a:avLst/>
-          </a:prstGeom>
-          <a:noFill/>
-          <a:ln/>
-        </p:spPr>
-        <p:txBody>
-          <a:bodyPr wrap="square" lIns="0" tIns="0" rIns="0" bIns="0" rtlCol="0" anchor="ctr"/>
-          <a:lstStyle/>
-          <a:p>
-            <a:pPr indent="0" marL="0">
-              <a:buNone/>
-            </a:pPr>
-            <a:r>
-              <a:rPr lang="en-US" sz="1100" dirty="0">
-                <a:solidFill>
-                  <a:srgbClr val="CFE8E6"/>
-                </a:solidFill>
-                <a:latin typeface="Calibri" pitchFamily="34" charset="0"/>
-                <a:ea typeface="Calibri" pitchFamily="34" charset="-122"/>
-                <a:cs typeface="Calibri" pitchFamily="34" charset="-120"/>
-              </a:rPr>
-              <a:t>zakelijke volgorde</a:t>
-            </a:r>
-            <a:endParaRPr lang="en-US" sz="1100" dirty="0"/>
-          </a:p>
-        </p:txBody>
-      </p:sp>
-      <p:sp>
-        <p:nvSpPr>
-          <p:cNvPr id="10" name="Shape 8"/>
-          <p:cNvSpPr/>
-          <p:nvPr/>
-        </p:nvSpPr>
-        <p:spPr>
-          <a:xfrm>
-            <a:off x="3547872" y="5029200"/>
-            <a:ext cx="2606040" cy="1188720"/>
+              <a:t>Demo 1 — het idee</a:t>
+            </a:r>
+            <a:endParaRPr lang="en-US" sz="1900" dirty="0"/>
+          </a:p>
+        </p:txBody>
+      </p:sp>
+      <p:sp>
+        <p:nvSpPr>
+          <p:cNvPr id="6" name="Text 4"/>
+          <p:cNvSpPr/>
+          <p:nvPr/>
+        </p:nvSpPr>
+        <p:spPr>
+          <a:xfrm>
+            <a:off x="932688" y="2404872"/>
+            <a:ext cx="4764024" cy="320040"/>
+          </a:xfrm>
+          <a:prstGeom prst="rect">
+            <a:avLst/>
+          </a:prstGeom>
+          <a:noFill/>
+          <a:ln/>
+        </p:spPr>
+        <p:txBody>
+          <a:bodyPr wrap="square" lIns="0" tIns="0" rIns="0" bIns="0" rtlCol="0" anchor="ctr"/>
+          <a:lstStyle/>
+          <a:p>
+            <a:pPr indent="0" marL="0">
+              <a:buNone/>
+            </a:pPr>
+            <a:r>
+              <a:rPr lang="en-US" sz="1200" b="1" i="1" dirty="0">
+                <a:solidFill>
+                  <a:srgbClr val="0FA3A3"/>
+                </a:solidFill>
+                <a:latin typeface="Calibri" pitchFamily="34" charset="0"/>
+                <a:ea typeface="Calibri" pitchFamily="34" charset="-122"/>
+                <a:cs typeface="Calibri" pitchFamily="34" charset="-120"/>
+              </a:rPr>
+              <a:t>10 min · misterchameleon.nl</a:t>
+            </a:r>
+            <a:endParaRPr lang="en-US" sz="1200" dirty="0"/>
+          </a:p>
+        </p:txBody>
+      </p:sp>
+      <p:sp>
+        <p:nvSpPr>
+          <p:cNvPr id="7" name="Text 5"/>
+          <p:cNvSpPr/>
+          <p:nvPr/>
+        </p:nvSpPr>
+        <p:spPr>
+          <a:xfrm>
+            <a:off x="932688" y="2807208"/>
+            <a:ext cx="4800600" cy="2286000"/>
+          </a:xfrm>
+          <a:prstGeom prst="rect">
+            <a:avLst/>
+          </a:prstGeom>
+          <a:noFill/>
+          <a:ln/>
+        </p:spPr>
+        <p:txBody>
+          <a:bodyPr wrap="square" lIns="0" tIns="0" rIns="0" bIns="0" rtlCol="0" anchor="ctr"/>
+          <a:lstStyle/>
+          <a:p>
+            <a:pPr marL="152400" indent="-152400">
+              <a:lnSpc>
+                <a:spcPct val="100000"/>
+              </a:lnSpc>
+              <a:spcAft>
+                <a:spcPts val="500"/>
+              </a:spcAft>
+              <a:buSzPct val="100000"/>
+              <a:buChar char="•"/>
+            </a:pPr>
+            <a:r>
+              <a:rPr lang="en-US" sz="1200" dirty="0">
+                <a:solidFill>
+                  <a:srgbClr val="5F7B88"/>
+                </a:solidFill>
+                <a:latin typeface="Calibri" pitchFamily="34" charset="0"/>
+                <a:ea typeface="Calibri" pitchFamily="34" charset="-122"/>
+                <a:cs typeface="Calibri" pitchFamily="34" charset="-120"/>
+              </a:rPr>
+              <a:t>Schakelaar uit handen: drie rollen, hij kiest zichzelf.</a:t>
+            </a:r>
+            <a:endParaRPr lang="en-US" sz="1200" dirty="0"/>
+          </a:p>
+          <a:p>
+            <a:pPr marL="152400" indent="-152400">
+              <a:lnSpc>
+                <a:spcPct val="100000"/>
+              </a:lnSpc>
+              <a:spcAft>
+                <a:spcPts val="500"/>
+              </a:spcAft>
+              <a:buSzPct val="100000"/>
+              <a:buChar char="•"/>
+            </a:pPr>
+            <a:r>
+              <a:rPr lang="en-US" sz="1200" dirty="0">
+                <a:solidFill>
+                  <a:srgbClr val="5F7B88"/>
+                </a:solidFill>
+                <a:latin typeface="Calibri" pitchFamily="34" charset="0"/>
+                <a:ea typeface="Calibri" pitchFamily="34" charset="-122"/>
+                <a:cs typeface="Calibri" pitchFamily="34" charset="-120"/>
+              </a:rPr>
+              <a:t>Alleen hero + cta wisselen; de rest blijft — de kameleon vloeit over.</a:t>
+            </a:r>
+            <a:endParaRPr lang="en-US" sz="1200" dirty="0"/>
+          </a:p>
+          <a:p>
+            <a:pPr marL="152400" indent="-152400">
+              <a:lnSpc>
+                <a:spcPct val="100000"/>
+              </a:lnSpc>
+              <a:spcAft>
+                <a:spcPts val="500"/>
+              </a:spcAft>
+              <a:buSzPct val="100000"/>
+              <a:buChar char="•"/>
+            </a:pPr>
+            <a:r>
+              <a:rPr lang="en-US" sz="1200" dirty="0">
+                <a:solidFill>
+                  <a:srgbClr val="5F7B88"/>
+                </a:solidFill>
+                <a:latin typeface="Calibri" pitchFamily="34" charset="0"/>
+                <a:ea typeface="Calibri" pitchFamily="34" charset="-122"/>
+                <a:cs typeface="Calibri" pitchFamily="34" charset="-120"/>
+              </a:rPr>
+              <a:t>Live profielpaneel terwijl hij rondklikt; tijdschuif naar avond/weekend.</a:t>
+            </a:r>
+            <a:endParaRPr lang="en-US" sz="1200" dirty="0"/>
+          </a:p>
+          <a:p>
+            <a:pPr marL="152400" indent="-152400">
+              <a:lnSpc>
+                <a:spcPct val="100000"/>
+              </a:lnSpc>
+              <a:spcAft>
+                <a:spcPts val="500"/>
+              </a:spcAft>
+              <a:buSzPct val="100000"/>
+              <a:buChar char="•"/>
+            </a:pPr>
+            <a:r>
+              <a:rPr lang="en-US" sz="1200" dirty="0">
+                <a:solidFill>
+                  <a:srgbClr val="5F7B88"/>
+                </a:solidFill>
+                <a:latin typeface="Calibri" pitchFamily="34" charset="0"/>
+                <a:ea typeface="Calibri" pitchFamily="34" charset="-122"/>
+                <a:cs typeface="Calibri" pitchFamily="34" charset="-120"/>
+              </a:rPr>
+              <a:t>Open de regels (3, gewone taal). Platform uit → gewone pagina.</a:t>
+            </a:r>
+            <a:endParaRPr lang="en-US" sz="1200" dirty="0"/>
+          </a:p>
+          <a:p>
+            <a:pPr marL="152400" indent="-152400">
+              <a:lnSpc>
+                <a:spcPct val="100000"/>
+              </a:lnSpc>
+              <a:spcAft>
+                <a:spcPts val="500"/>
+              </a:spcAft>
+              <a:buSzPct val="100000"/>
+              <a:buChar char="•"/>
+            </a:pPr>
+            <a:r>
+              <a:rPr lang="en-US" sz="1200" dirty="0">
+                <a:solidFill>
+                  <a:srgbClr val="5F7B88"/>
+                </a:solidFill>
+                <a:latin typeface="Calibri" pitchFamily="34" charset="0"/>
+                <a:ea typeface="Calibri" pitchFamily="34" charset="-122"/>
+                <a:cs typeface="Calibri" pitchFamily="34" charset="-120"/>
+              </a:rPr>
+              <a:t>Weglaten: verrijking, AI, e-mail, formulieren.</a:t>
+            </a:r>
+            <a:endParaRPr lang="en-US" sz="1200" dirty="0"/>
+          </a:p>
+        </p:txBody>
+      </p:sp>
+      <p:sp>
+        <p:nvSpPr>
+          <p:cNvPr id="8" name="Shape 6"/>
+          <p:cNvSpPr/>
+          <p:nvPr/>
+        </p:nvSpPr>
+        <p:spPr>
+          <a:xfrm>
+            <a:off x="6263640" y="1783080"/>
+            <a:ext cx="5349240" cy="3429000"/>
           </a:xfrm>
           <a:prstGeom prst="roundRect">
             <a:avLst>
-              <a:gd name="adj" fmla="val 6923"/>
+              <a:gd name="adj" fmla="val 2400"/>
             </a:avLst>
           </a:prstGeom>
           <a:solidFill>
-            <a:srgbClr val="12414E"/>
+            <a:srgbClr val="E4F5F1"/>
           </a:solidFill>
           <a:ln/>
           <a:effectLst>
@@ -8766,470 +8807,263 @@
       </p:sp>
       <p:sp>
         <p:nvSpPr>
-          <p:cNvPr id="11" name="Shape 9"/>
-          <p:cNvSpPr/>
-          <p:nvPr/>
-        </p:nvSpPr>
-        <p:spPr>
-          <a:xfrm>
-            <a:off x="3776472" y="5257800"/>
-            <a:ext cx="457200" cy="457200"/>
-          </a:xfrm>
-          <a:prstGeom prst="ellipse">
-            <a:avLst/>
-          </a:prstGeom>
-          <a:solidFill>
-            <a:srgbClr val="17C3B2"/>
-          </a:solidFill>
-          <a:ln/>
-        </p:spPr>
-      </p:sp>
-      <p:sp>
-        <p:nvSpPr>
-          <p:cNvPr id="12" name="Text 10"/>
-          <p:cNvSpPr/>
-          <p:nvPr/>
-        </p:nvSpPr>
-        <p:spPr>
-          <a:xfrm>
-            <a:off x="3776472" y="5257800"/>
-            <a:ext cx="457200" cy="457200"/>
-          </a:xfrm>
-          <a:prstGeom prst="rect">
-            <a:avLst/>
-          </a:prstGeom>
-          <a:noFill/>
-          <a:ln/>
-        </p:spPr>
-        <p:txBody>
-          <a:bodyPr wrap="square" lIns="0" tIns="0" rIns="0" bIns="0" rtlCol="0" anchor="ctr"/>
-          <a:lstStyle/>
-          <a:p>
-            <a:pPr algn="ctr" indent="0" marL="0">
-              <a:buNone/>
-            </a:pPr>
-            <a:r>
-              <a:rPr lang="en-US" sz="1500" b="1" dirty="0">
-                <a:solidFill>
-                  <a:srgbClr val="FFFFFF"/>
+          <p:cNvPr id="9" name="Text 7"/>
+          <p:cNvSpPr/>
+          <p:nvPr/>
+        </p:nvSpPr>
+        <p:spPr>
+          <a:xfrm>
+            <a:off x="6556248" y="2002536"/>
+            <a:ext cx="4764024" cy="365760"/>
+          </a:xfrm>
+          <a:prstGeom prst="rect">
+            <a:avLst/>
+          </a:prstGeom>
+          <a:noFill/>
+          <a:ln/>
+        </p:spPr>
+        <p:txBody>
+          <a:bodyPr wrap="square" lIns="0" tIns="0" rIns="0" bIns="0" rtlCol="0" anchor="ctr"/>
+          <a:lstStyle/>
+          <a:p>
+            <a:pPr indent="0" marL="0">
+              <a:buNone/>
+            </a:pPr>
+            <a:r>
+              <a:rPr lang="en-US" sz="1900" b="1" dirty="0">
+                <a:solidFill>
+                  <a:srgbClr val="17303A"/>
                 </a:solidFill>
                 <a:latin typeface="Cambria" pitchFamily="34" charset="0"/>
                 <a:ea typeface="Cambria" pitchFamily="34" charset="-122"/>
                 <a:cs typeface="Cambria" pitchFamily="34" charset="-120"/>
               </a:rPr>
-              <a:t>2</a:t>
-            </a:r>
-            <a:endParaRPr lang="en-US" sz="1500" dirty="0"/>
-          </a:p>
-        </p:txBody>
-      </p:sp>
-      <p:sp>
-        <p:nvSpPr>
-          <p:cNvPr id="13" name="Text 11"/>
-          <p:cNvSpPr/>
-          <p:nvPr/>
-        </p:nvSpPr>
-        <p:spPr>
-          <a:xfrm>
-            <a:off x="4370832" y="5212080"/>
-            <a:ext cx="1691640" cy="365760"/>
-          </a:xfrm>
-          <a:prstGeom prst="rect">
-            <a:avLst/>
-          </a:prstGeom>
-          <a:noFill/>
-          <a:ln/>
-        </p:spPr>
-        <p:txBody>
-          <a:bodyPr wrap="square" lIns="0" tIns="0" rIns="0" bIns="0" rtlCol="0" anchor="ctr"/>
-          <a:lstStyle/>
-          <a:p>
-            <a:pPr indent="0" marL="0">
-              <a:buNone/>
-            </a:pPr>
-            <a:r>
-              <a:rPr lang="en-US" sz="1400" b="1" dirty="0">
-                <a:solidFill>
-                  <a:srgbClr val="FFFFFF"/>
-                </a:solidFill>
-                <a:latin typeface="Calibri" pitchFamily="34" charset="0"/>
-                <a:ea typeface="Calibri" pitchFamily="34" charset="-122"/>
-                <a:cs typeface="Calibri" pitchFamily="34" charset="-120"/>
-              </a:rPr>
-              <a:t>Sollicitant</a:t>
-            </a:r>
-            <a:endParaRPr lang="en-US" sz="1400" dirty="0"/>
-          </a:p>
-        </p:txBody>
-      </p:sp>
-      <p:sp>
-        <p:nvSpPr>
-          <p:cNvPr id="14" name="Text 12"/>
-          <p:cNvSpPr/>
-          <p:nvPr/>
-        </p:nvSpPr>
-        <p:spPr>
-          <a:xfrm>
-            <a:off x="3803904" y="5742432"/>
-            <a:ext cx="2194560" cy="365760"/>
-          </a:xfrm>
-          <a:prstGeom prst="rect">
-            <a:avLst/>
-          </a:prstGeom>
-          <a:noFill/>
-          <a:ln/>
-        </p:spPr>
-        <p:txBody>
-          <a:bodyPr wrap="square" lIns="0" tIns="0" rIns="0" bIns="0" rtlCol="0" anchor="ctr"/>
-          <a:lstStyle/>
-          <a:p>
-            <a:pPr indent="0" marL="0">
-              <a:buNone/>
-            </a:pPr>
-            <a:r>
-              <a:rPr lang="en-US" sz="1100" dirty="0">
-                <a:solidFill>
-                  <a:srgbClr val="CFE8E6"/>
-                </a:solidFill>
-                <a:latin typeface="Calibri" pitchFamily="34" charset="0"/>
-                <a:ea typeface="Calibri" pitchFamily="34" charset="-122"/>
-                <a:cs typeface="Calibri" pitchFamily="34" charset="-120"/>
-              </a:rPr>
-              <a:t>vacature leidt</a:t>
-            </a:r>
-            <a:endParaRPr lang="en-US" sz="1100" dirty="0"/>
-          </a:p>
-        </p:txBody>
-      </p:sp>
-      <p:sp>
-        <p:nvSpPr>
-          <p:cNvPr id="15" name="Shape 13"/>
-          <p:cNvSpPr/>
-          <p:nvPr/>
-        </p:nvSpPr>
-        <p:spPr>
-          <a:xfrm>
-            <a:off x="6272784" y="5029200"/>
-            <a:ext cx="2606040" cy="1188720"/>
-          </a:xfrm>
-          <a:prstGeom prst="roundRect">
-            <a:avLst>
-              <a:gd name="adj" fmla="val 6923"/>
-            </a:avLst>
-          </a:prstGeom>
-          <a:solidFill>
-            <a:srgbClr val="12414E"/>
-          </a:solidFill>
-          <a:ln/>
-          <a:effectLst>
-            <a:outerShdw sx="100000" sy="100000" kx="0" ky="0" algn="bl" rotWithShape="0" blurRad="76200" dist="25400" dir="5400000">
-              <a:srgbClr val="9FB6B6">
-                <a:alpha val="28000"/>
-              </a:srgbClr>
-            </a:outerShdw>
-          </a:effectLst>
-        </p:spPr>
-      </p:sp>
-      <p:sp>
-        <p:nvSpPr>
-          <p:cNvPr id="16" name="Shape 14"/>
-          <p:cNvSpPr/>
-          <p:nvPr/>
-        </p:nvSpPr>
-        <p:spPr>
-          <a:xfrm>
-            <a:off x="6501384" y="5257800"/>
-            <a:ext cx="457200" cy="457200"/>
-          </a:xfrm>
-          <a:prstGeom prst="ellipse">
-            <a:avLst/>
-          </a:prstGeom>
-          <a:solidFill>
-            <a:srgbClr val="17C3B2"/>
-          </a:solidFill>
-          <a:ln/>
-        </p:spPr>
-      </p:sp>
-      <p:sp>
-        <p:nvSpPr>
-          <p:cNvPr id="17" name="Text 15"/>
-          <p:cNvSpPr/>
-          <p:nvPr/>
-        </p:nvSpPr>
-        <p:spPr>
-          <a:xfrm>
-            <a:off x="6501384" y="5257800"/>
-            <a:ext cx="457200" cy="457200"/>
-          </a:xfrm>
-          <a:prstGeom prst="rect">
-            <a:avLst/>
-          </a:prstGeom>
-          <a:noFill/>
-          <a:ln/>
-        </p:spPr>
-        <p:txBody>
-          <a:bodyPr wrap="square" lIns="0" tIns="0" rIns="0" bIns="0" rtlCol="0" anchor="ctr"/>
-          <a:lstStyle/>
-          <a:p>
-            <a:pPr algn="ctr" indent="0" marL="0">
-              <a:buNone/>
-            </a:pPr>
-            <a:r>
-              <a:rPr lang="en-US" sz="1500" b="1" dirty="0">
-                <a:solidFill>
-                  <a:srgbClr val="FFFFFF"/>
-                </a:solidFill>
-                <a:latin typeface="Cambria" pitchFamily="34" charset="0"/>
-                <a:ea typeface="Cambria" pitchFamily="34" charset="-122"/>
-                <a:cs typeface="Cambria" pitchFamily="34" charset="-120"/>
-              </a:rPr>
-              <a:t>3</a:t>
-            </a:r>
-            <a:endParaRPr lang="en-US" sz="1500" dirty="0"/>
-          </a:p>
-        </p:txBody>
-      </p:sp>
-      <p:sp>
-        <p:nvSpPr>
-          <p:cNvPr id="18" name="Text 16"/>
-          <p:cNvSpPr/>
-          <p:nvPr/>
-        </p:nvSpPr>
-        <p:spPr>
-          <a:xfrm>
-            <a:off x="7095744" y="5212080"/>
-            <a:ext cx="1691640" cy="365760"/>
-          </a:xfrm>
-          <a:prstGeom prst="rect">
-            <a:avLst/>
-          </a:prstGeom>
-          <a:noFill/>
-          <a:ln/>
-        </p:spPr>
-        <p:txBody>
-          <a:bodyPr wrap="square" lIns="0" tIns="0" rIns="0" bIns="0" rtlCol="0" anchor="ctr"/>
-          <a:lstStyle/>
-          <a:p>
-            <a:pPr indent="0" marL="0">
-              <a:buNone/>
-            </a:pPr>
-            <a:r>
-              <a:rPr lang="en-US" sz="1400" b="1" dirty="0">
-                <a:solidFill>
-                  <a:srgbClr val="FFFFFF"/>
-                </a:solidFill>
-                <a:latin typeface="Calibri" pitchFamily="34" charset="0"/>
-                <a:ea typeface="Calibri" pitchFamily="34" charset="-122"/>
-                <a:cs typeface="Calibri" pitchFamily="34" charset="-120"/>
-              </a:rPr>
-              <a:t>Bekende klant</a:t>
-            </a:r>
-            <a:endParaRPr lang="en-US" sz="1400" dirty="0"/>
-          </a:p>
-        </p:txBody>
-      </p:sp>
-      <p:sp>
-        <p:nvSpPr>
-          <p:cNvPr id="19" name="Text 17"/>
-          <p:cNvSpPr/>
-          <p:nvPr/>
-        </p:nvSpPr>
-        <p:spPr>
-          <a:xfrm>
-            <a:off x="6528816" y="5742432"/>
-            <a:ext cx="2194560" cy="365760"/>
-          </a:xfrm>
-          <a:prstGeom prst="rect">
-            <a:avLst/>
-          </a:prstGeom>
-          <a:noFill/>
-          <a:ln/>
-        </p:spPr>
-        <p:txBody>
-          <a:bodyPr wrap="square" lIns="0" tIns="0" rIns="0" bIns="0" rtlCol="0" anchor="ctr"/>
-          <a:lstStyle/>
-          <a:p>
-            <a:pPr indent="0" marL="0">
-              <a:buNone/>
-            </a:pPr>
-            <a:r>
-              <a:rPr lang="en-US" sz="1100" dirty="0">
-                <a:solidFill>
-                  <a:srgbClr val="CFE8E6"/>
-                </a:solidFill>
-                <a:latin typeface="Calibri" pitchFamily="34" charset="0"/>
-                <a:ea typeface="Calibri" pitchFamily="34" charset="-122"/>
-                <a:cs typeface="Calibri" pitchFamily="34" charset="-120"/>
-              </a:rPr>
-              <a:t>retentie i.p.v. acquisitie</a:t>
-            </a:r>
-            <a:endParaRPr lang="en-US" sz="1100" dirty="0"/>
-          </a:p>
-        </p:txBody>
-      </p:sp>
-      <p:sp>
-        <p:nvSpPr>
-          <p:cNvPr id="20" name="Shape 18"/>
-          <p:cNvSpPr/>
-          <p:nvPr/>
-        </p:nvSpPr>
-        <p:spPr>
-          <a:xfrm>
-            <a:off x="8997696" y="5029200"/>
-            <a:ext cx="2606040" cy="1188720"/>
-          </a:xfrm>
-          <a:prstGeom prst="roundRect">
-            <a:avLst>
-              <a:gd name="adj" fmla="val 6923"/>
-            </a:avLst>
-          </a:prstGeom>
-          <a:solidFill>
-            <a:srgbClr val="12414E"/>
-          </a:solidFill>
-          <a:ln/>
-          <a:effectLst>
-            <a:outerShdw sx="100000" sy="100000" kx="0" ky="0" algn="bl" rotWithShape="0" blurRad="76200" dist="25400" dir="5400000">
-              <a:srgbClr val="9FB6B6">
-                <a:alpha val="28000"/>
-              </a:srgbClr>
-            </a:outerShdw>
-          </a:effectLst>
-        </p:spPr>
-      </p:sp>
-      <p:sp>
-        <p:nvSpPr>
-          <p:cNvPr id="21" name="Shape 19"/>
-          <p:cNvSpPr/>
-          <p:nvPr/>
-        </p:nvSpPr>
-        <p:spPr>
-          <a:xfrm>
-            <a:off x="9226296" y="5257800"/>
-            <a:ext cx="457200" cy="457200"/>
-          </a:xfrm>
-          <a:prstGeom prst="ellipse">
-            <a:avLst/>
-          </a:prstGeom>
-          <a:solidFill>
-            <a:srgbClr val="17C3B2"/>
-          </a:solidFill>
-          <a:ln/>
-        </p:spPr>
-      </p:sp>
-      <p:sp>
-        <p:nvSpPr>
-          <p:cNvPr id="22" name="Text 20"/>
-          <p:cNvSpPr/>
-          <p:nvPr/>
-        </p:nvSpPr>
-        <p:spPr>
-          <a:xfrm>
-            <a:off x="9226296" y="5257800"/>
-            <a:ext cx="457200" cy="457200"/>
-          </a:xfrm>
-          <a:prstGeom prst="rect">
-            <a:avLst/>
-          </a:prstGeom>
-          <a:noFill/>
-          <a:ln/>
-        </p:spPr>
-        <p:txBody>
-          <a:bodyPr wrap="square" lIns="0" tIns="0" rIns="0" bIns="0" rtlCol="0" anchor="ctr"/>
-          <a:lstStyle/>
-          <a:p>
-            <a:pPr algn="ctr" indent="0" marL="0">
-              <a:buNone/>
-            </a:pPr>
-            <a:r>
-              <a:rPr lang="en-US" sz="1500" b="1" dirty="0">
-                <a:solidFill>
-                  <a:srgbClr val="FFFFFF"/>
-                </a:solidFill>
-                <a:latin typeface="Cambria" pitchFamily="34" charset="0"/>
-                <a:ea typeface="Cambria" pitchFamily="34" charset="-122"/>
-                <a:cs typeface="Cambria" pitchFamily="34" charset="-120"/>
-              </a:rPr>
-              <a:t>4</a:t>
-            </a:r>
-            <a:endParaRPr lang="en-US" sz="1500" dirty="0"/>
-          </a:p>
-        </p:txBody>
-      </p:sp>
-      <p:sp>
-        <p:nvSpPr>
-          <p:cNvPr id="23" name="Text 21"/>
-          <p:cNvSpPr/>
-          <p:nvPr/>
-        </p:nvSpPr>
-        <p:spPr>
-          <a:xfrm>
-            <a:off x="9820656" y="5212080"/>
-            <a:ext cx="1691640" cy="365760"/>
-          </a:xfrm>
-          <a:prstGeom prst="rect">
-            <a:avLst/>
-          </a:prstGeom>
-          <a:noFill/>
-          <a:ln/>
-        </p:spPr>
-        <p:txBody>
-          <a:bodyPr wrap="square" lIns="0" tIns="0" rIns="0" bIns="0" rtlCol="0" anchor="ctr"/>
-          <a:lstStyle/>
-          <a:p>
-            <a:pPr indent="0" marL="0">
-              <a:buNone/>
-            </a:pPr>
-            <a:r>
-              <a:rPr lang="en-US" sz="1400" b="1" dirty="0">
-                <a:solidFill>
-                  <a:srgbClr val="FFFFFF"/>
-                </a:solidFill>
-                <a:latin typeface="Calibri" pitchFamily="34" charset="0"/>
-                <a:ea typeface="Calibri" pitchFamily="34" charset="-122"/>
-                <a:cs typeface="Calibri" pitchFamily="34" charset="-120"/>
-              </a:rPr>
-              <a:t>Campagne</a:t>
-            </a:r>
-            <a:endParaRPr lang="en-US" sz="1400" dirty="0"/>
-          </a:p>
-        </p:txBody>
-      </p:sp>
-      <p:sp>
-        <p:nvSpPr>
-          <p:cNvPr id="24" name="Text 22"/>
-          <p:cNvSpPr/>
-          <p:nvPr/>
-        </p:nvSpPr>
-        <p:spPr>
-          <a:xfrm>
-            <a:off x="9253728" y="5742432"/>
-            <a:ext cx="2194560" cy="365760"/>
-          </a:xfrm>
-          <a:prstGeom prst="rect">
-            <a:avLst/>
-          </a:prstGeom>
-          <a:noFill/>
-          <a:ln/>
-        </p:spPr>
-        <p:txBody>
-          <a:bodyPr wrap="square" lIns="0" tIns="0" rIns="0" bIns="0" rtlCol="0" anchor="ctr"/>
-          <a:lstStyle/>
-          <a:p>
-            <a:pPr indent="0" marL="0">
-              <a:buNone/>
-            </a:pPr>
-            <a:r>
-              <a:rPr lang="en-US" sz="1100" dirty="0">
-                <a:solidFill>
-                  <a:srgbClr val="CFE8E6"/>
-                </a:solidFill>
-                <a:latin typeface="Calibri" pitchFamily="34" charset="0"/>
-                <a:ea typeface="Calibri" pitchFamily="34" charset="-122"/>
-                <a:cs typeface="Calibri" pitchFamily="34" charset="-120"/>
-              </a:rPr>
-              <a:t>landing = advertentie</a:t>
-            </a:r>
-            <a:endParaRPr lang="en-US" sz="1100" dirty="0"/>
+              <a:t>Demo 2 — de diepte</a:t>
+            </a:r>
+            <a:endParaRPr lang="en-US" sz="1900" dirty="0"/>
+          </a:p>
+        </p:txBody>
+      </p:sp>
+      <p:sp>
+        <p:nvSpPr>
+          <p:cNvPr id="10" name="Text 8"/>
+          <p:cNvSpPr/>
+          <p:nvPr/>
+        </p:nvSpPr>
+        <p:spPr>
+          <a:xfrm>
+            <a:off x="6556248" y="2404872"/>
+            <a:ext cx="4764024" cy="320040"/>
+          </a:xfrm>
+          <a:prstGeom prst="rect">
+            <a:avLst/>
+          </a:prstGeom>
+          <a:noFill/>
+          <a:ln/>
+        </p:spPr>
+        <p:txBody>
+          <a:bodyPr wrap="square" lIns="0" tIns="0" rIns="0" bIns="0" rtlCol="0" anchor="ctr"/>
+          <a:lstStyle/>
+          <a:p>
+            <a:pPr indent="0" marL="0">
+              <a:buNone/>
+            </a:pPr>
+            <a:r>
+              <a:rPr lang="en-US" sz="1200" b="1" i="1" dirty="0">
+                <a:solidFill>
+                  <a:srgbClr val="0FA3A3"/>
+                </a:solidFill>
+                <a:latin typeface="Calibri" pitchFamily="34" charset="0"/>
+                <a:ea typeface="Calibri" pitchFamily="34" charset="-122"/>
+                <a:cs typeface="Calibri" pitchFamily="34" charset="-120"/>
+              </a:rPr>
+              <a:t>apart moment, andere vraag</a:t>
+            </a:r>
+            <a:endParaRPr lang="en-US" sz="1200" dirty="0"/>
+          </a:p>
+        </p:txBody>
+      </p:sp>
+      <p:sp>
+        <p:nvSpPr>
+          <p:cNvPr id="11" name="Text 9"/>
+          <p:cNvSpPr/>
+          <p:nvPr/>
+        </p:nvSpPr>
+        <p:spPr>
+          <a:xfrm>
+            <a:off x="6556248" y="2807208"/>
+            <a:ext cx="4800600" cy="2286000"/>
+          </a:xfrm>
+          <a:prstGeom prst="rect">
+            <a:avLst/>
+          </a:prstGeom>
+          <a:noFill/>
+          <a:ln/>
+        </p:spPr>
+        <p:txBody>
+          <a:bodyPr wrap="square" lIns="0" tIns="0" rIns="0" bIns="0" rtlCol="0" anchor="ctr"/>
+          <a:lstStyle/>
+          <a:p>
+            <a:pPr marL="152400" indent="-152400">
+              <a:lnSpc>
+                <a:spcPct val="100000"/>
+              </a:lnSpc>
+              <a:spcAft>
+                <a:spcPts val="500"/>
+              </a:spcAft>
+              <a:buSzPct val="100000"/>
+              <a:buChar char="•"/>
+            </a:pPr>
+            <a:r>
+              <a:rPr lang="en-US" sz="1200" dirty="0">
+                <a:solidFill>
+                  <a:srgbClr val="5F7B88"/>
+                </a:solidFill>
+                <a:latin typeface="Calibri" pitchFamily="34" charset="0"/>
+                <a:ea typeface="Calibri" pitchFamily="34" charset="-122"/>
+                <a:cs typeface="Calibri" pitchFamily="34" charset="-120"/>
+              </a:rPr>
+              <a:t>Open: “wat we bewijzen, niet wat we dag één verkopen.”</a:t>
+            </a:r>
+            <a:endParaRPr lang="en-US" sz="1200" dirty="0"/>
+          </a:p>
+          <a:p>
+            <a:pPr marL="152400" indent="-152400">
+              <a:lnSpc>
+                <a:spcPct val="100000"/>
+              </a:lnSpc>
+              <a:spcAft>
+                <a:spcPts val="500"/>
+              </a:spcAft>
+              <a:buSzPct val="100000"/>
+              <a:buChar char="•"/>
+            </a:pPr>
+            <a:r>
+              <a:rPr lang="en-US" sz="1200" dirty="0">
+                <a:solidFill>
+                  <a:srgbClr val="5F7B88"/>
+                </a:solidFill>
+                <a:latin typeface="Calibri" pitchFamily="34" charset="0"/>
+                <a:ea typeface="Calibri" pitchFamily="34" charset="-122"/>
+                <a:cs typeface="Calibri" pitchFamily="34" charset="-120"/>
+              </a:rPr>
+              <a:t>Verrijking + terughoudendheid + uitsluitingslijst (voor de creepy-vraag).</a:t>
+            </a:r>
+            <a:endParaRPr lang="en-US" sz="1200" dirty="0"/>
+          </a:p>
+          <a:p>
+            <a:pPr marL="152400" indent="-152400">
+              <a:lnSpc>
+                <a:spcPct val="100000"/>
+              </a:lnSpc>
+              <a:spcAft>
+                <a:spcPts val="500"/>
+              </a:spcAft>
+              <a:buSzPct val="100000"/>
+              <a:buChar char="•"/>
+            </a:pPr>
+            <a:r>
+              <a:rPr lang="en-US" sz="1200" dirty="0">
+                <a:solidFill>
+                  <a:srgbClr val="5F7B88"/>
+                </a:solidFill>
+                <a:latin typeface="Calibri" pitchFamily="34" charset="0"/>
+                <a:ea typeface="Calibri" pitchFamily="34" charset="-122"/>
+                <a:cs typeface="Calibri" pitchFamily="34" charset="-120"/>
+              </a:rPr>
+              <a:t>Formuliervarianten · adaptieve e-mail (continuïteit).</a:t>
+            </a:r>
+            <a:endParaRPr lang="en-US" sz="1200" dirty="0"/>
+          </a:p>
+          <a:p>
+            <a:pPr marL="152400" indent="-152400">
+              <a:lnSpc>
+                <a:spcPct val="100000"/>
+              </a:lnSpc>
+              <a:spcAft>
+                <a:spcPts val="500"/>
+              </a:spcAft>
+              <a:buSzPct val="100000"/>
+              <a:buChar char="•"/>
+            </a:pPr>
+            <a:r>
+              <a:rPr lang="en-US" sz="1200" dirty="0">
+                <a:solidFill>
+                  <a:srgbClr val="5F7B88"/>
+                </a:solidFill>
+                <a:latin typeface="Calibri" pitchFamily="34" charset="0"/>
+                <a:ea typeface="Calibri" pitchFamily="34" charset="-122"/>
+                <a:cs typeface="Calibri" pitchFamily="34" charset="-120"/>
+              </a:rPr>
+              <a:t>AI-generator: 4 hero's, gooi er zelf 2 weg — jullie snelheid.</a:t>
+            </a:r>
+            <a:endParaRPr lang="en-US" sz="1200" dirty="0"/>
+          </a:p>
+          <a:p>
+            <a:pPr marL="152400" indent="-152400">
+              <a:lnSpc>
+                <a:spcPct val="100000"/>
+              </a:lnSpc>
+              <a:spcAft>
+                <a:spcPts val="500"/>
+              </a:spcAft>
+              <a:buSzPct val="100000"/>
+              <a:buChar char="•"/>
+            </a:pPr>
+            <a:r>
+              <a:rPr lang="en-US" sz="1200" dirty="0">
+                <a:solidFill>
+                  <a:srgbClr val="5F7B88"/>
+                </a:solidFill>
+                <a:latin typeface="Calibri" pitchFamily="34" charset="0"/>
+                <a:ea typeface="Calibri" pitchFamily="34" charset="-122"/>
+                <a:cs typeface="Calibri" pitchFamily="34" charset="-120"/>
+              </a:rPr>
+              <a:t>Meetlaag: welke regels vuurden, verdeling, welke nooit. Per onderdeel een statuszin.</a:t>
+            </a:r>
+            <a:endParaRPr lang="en-US" sz="1200" dirty="0"/>
+          </a:p>
+        </p:txBody>
+      </p:sp>
+      <p:sp>
+        <p:nvSpPr>
+          <p:cNvPr id="12" name="Text 10"/>
+          <p:cNvSpPr/>
+          <p:nvPr/>
+        </p:nvSpPr>
+        <p:spPr>
+          <a:xfrm>
+            <a:off x="640080" y="5440680"/>
+            <a:ext cx="10881360" cy="640080"/>
+          </a:xfrm>
+          <a:prstGeom prst="rect">
+            <a:avLst/>
+          </a:prstGeom>
+          <a:noFill/>
+          <a:ln/>
+        </p:spPr>
+        <p:txBody>
+          <a:bodyPr wrap="square" lIns="0" tIns="0" rIns="0" bIns="0" rtlCol="0" anchor="ctr"/>
+          <a:lstStyle/>
+          <a:p>
+            <a:pPr indent="0" marL="0">
+              <a:lnSpc>
+                <a:spcPct val="108000"/>
+              </a:lnSpc>
+              <a:buNone/>
+            </a:pPr>
+            <a:r>
+              <a:rPr lang="en-US" sz="1300" b="1" i="1" dirty="0">
+                <a:solidFill>
+                  <a:srgbClr val="0FA3A3"/>
+                </a:solidFill>
+                <a:latin typeface="Calibri" pitchFamily="34" charset="0"/>
+                <a:ea typeface="Calibri" pitchFamily="34" charset="-122"/>
+                <a:cs typeface="Calibri" pitchFamily="34" charset="-120"/>
+              </a:rPr>
+              <a:t>Eigen site overtuigt van het idee, hun site (mirror) van de toepassing. Sterkste contrast: sollicitant vs. klant. Na de kern: stoppen met vertellen — de vraag die zij stellen is het doel.</a:t>
+            </a:r>
+            <a:endParaRPr lang="en-US" sz="1300" dirty="0"/>
           </a:p>
         </p:txBody>
       </p:sp>
@@ -11344,7 +11178,7 @@
                 <a:ea typeface="Calibri" pitchFamily="34" charset="-122"/>
                 <a:cs typeface="Calibri" pitchFamily="34" charset="-120"/>
               </a:rPr>
-              <a:t>Contextuele personalisatie met een server-side beslissing en een veilige default.</a:t>
+              <a:t>De boodschap blijft, de vorm past zich aan de context — de kleur verandert, niet het dier.</a:t>
             </a:r>
             <a:endParaRPr lang="en-US" sz="1500" dirty="0"/>
           </a:p>

</xml_diff>